<commit_message>
Update the LAB3 workflow deck and drop the superseded one
</commit_message>
<xml_diff>
--- a/LAB3/LAB3-RAG-Workflow-Simple.pptx
+++ b/LAB3/LAB3-RAG-Workflow-Simple.pptx
@@ -303,7 +303,7 @@
           <a:p>
             <a:fld id="{5BCAD085-E8A6-8845-BD4E-CB4CCA059FC4}" type="datetimeFigureOut">
               <a:rPr lang="en-US" smtClean="0"/>
-              <a:t>8/18/26</a:t>
+              <a:t>8/19/26</a:t>
             </a:fld>
             <a:endParaRPr lang="en-US"/>
           </a:p>
@@ -471,7 +471,7 @@
           <a:p>
             <a:fld id="{5BCAD085-E8A6-8845-BD4E-CB4CCA059FC4}" type="datetimeFigureOut">
               <a:rPr lang="en-US" smtClean="0"/>
-              <a:t>8/18/26</a:t>
+              <a:t>8/19/26</a:t>
             </a:fld>
             <a:endParaRPr lang="en-US"/>
           </a:p>
@@ -649,7 +649,7 @@
           <a:p>
             <a:fld id="{5BCAD085-E8A6-8845-BD4E-CB4CCA059FC4}" type="datetimeFigureOut">
               <a:rPr lang="en-US" smtClean="0"/>
-              <a:t>8/18/26</a:t>
+              <a:t>8/19/26</a:t>
             </a:fld>
             <a:endParaRPr lang="en-US"/>
           </a:p>
@@ -817,7 +817,7 @@
           <a:p>
             <a:fld id="{5BCAD085-E8A6-8845-BD4E-CB4CCA059FC4}" type="datetimeFigureOut">
               <a:rPr lang="en-US" smtClean="0"/>
-              <a:t>8/18/26</a:t>
+              <a:t>8/19/26</a:t>
             </a:fld>
             <a:endParaRPr lang="en-US"/>
           </a:p>
@@ -1062,7 +1062,7 @@
           <a:p>
             <a:fld id="{5BCAD085-E8A6-8845-BD4E-CB4CCA059FC4}" type="datetimeFigureOut">
               <a:rPr lang="en-US" smtClean="0"/>
-              <a:t>8/18/26</a:t>
+              <a:t>8/19/26</a:t>
             </a:fld>
             <a:endParaRPr lang="en-US"/>
           </a:p>
@@ -1347,7 +1347,7 @@
           <a:p>
             <a:fld id="{5BCAD085-E8A6-8845-BD4E-CB4CCA059FC4}" type="datetimeFigureOut">
               <a:rPr lang="en-US" smtClean="0"/>
-              <a:t>8/18/26</a:t>
+              <a:t>8/19/26</a:t>
             </a:fld>
             <a:endParaRPr lang="en-US"/>
           </a:p>
@@ -1766,7 +1766,7 @@
           <a:p>
             <a:fld id="{5BCAD085-E8A6-8845-BD4E-CB4CCA059FC4}" type="datetimeFigureOut">
               <a:rPr lang="en-US" smtClean="0"/>
-              <a:t>8/18/26</a:t>
+              <a:t>8/19/26</a:t>
             </a:fld>
             <a:endParaRPr lang="en-US"/>
           </a:p>
@@ -1883,7 +1883,7 @@
           <a:p>
             <a:fld id="{5BCAD085-E8A6-8845-BD4E-CB4CCA059FC4}" type="datetimeFigureOut">
               <a:rPr lang="en-US" smtClean="0"/>
-              <a:t>8/18/26</a:t>
+              <a:t>8/19/26</a:t>
             </a:fld>
             <a:endParaRPr lang="en-US"/>
           </a:p>
@@ -1978,7 +1978,7 @@
           <a:p>
             <a:fld id="{5BCAD085-E8A6-8845-BD4E-CB4CCA059FC4}" type="datetimeFigureOut">
               <a:rPr lang="en-US" smtClean="0"/>
-              <a:t>8/18/26</a:t>
+              <a:t>8/19/26</a:t>
             </a:fld>
             <a:endParaRPr lang="en-US"/>
           </a:p>
@@ -2253,7 +2253,7 @@
           <a:p>
             <a:fld id="{5BCAD085-E8A6-8845-BD4E-CB4CCA059FC4}" type="datetimeFigureOut">
               <a:rPr lang="en-US" smtClean="0"/>
-              <a:t>8/18/26</a:t>
+              <a:t>8/19/26</a:t>
             </a:fld>
             <a:endParaRPr lang="en-US"/>
           </a:p>
@@ -2505,7 +2505,7 @@
           <a:p>
             <a:fld id="{5BCAD085-E8A6-8845-BD4E-CB4CCA059FC4}" type="datetimeFigureOut">
               <a:rPr lang="en-US" smtClean="0"/>
-              <a:t>8/18/26</a:t>
+              <a:t>8/19/26</a:t>
             </a:fld>
             <a:endParaRPr lang="en-US"/>
           </a:p>
@@ -2716,7 +2716,7 @@
           <a:p>
             <a:fld id="{5BCAD085-E8A6-8845-BD4E-CB4CCA059FC4}" type="datetimeFigureOut">
               <a:rPr lang="en-US" smtClean="0"/>
-              <a:t>8/18/26</a:t>
+              <a:t>8/19/26</a:t>
             </a:fld>
             <a:endParaRPr lang="en-US"/>
           </a:p>
@@ -3093,163 +3093,6 @@
       </p:grpSpPr>
       <p:sp>
         <p:nvSpPr>
-          <p:cNvPr id="2" name="Rectangle 1"/>
-          <p:cNvSpPr/>
-          <p:nvPr/>
-        </p:nvSpPr>
-        <p:spPr>
-          <a:xfrm>
-            <a:off x="0" y="0"/>
-            <a:ext cx="12191695" cy="868680"/>
-          </a:xfrm>
-          <a:prstGeom prst="rect">
-            <a:avLst/>
-          </a:prstGeom>
-          <a:solidFill>
-            <a:srgbClr val="11223A"/>
-          </a:solidFill>
-          <a:ln>
-            <a:noFill/>
-          </a:ln>
-          <a:effectLst/>
-        </p:spPr>
-        <p:style>
-          <a:lnRef idx="1">
-            <a:schemeClr val="accent1"/>
-          </a:lnRef>
-          <a:fillRef idx="3">
-            <a:schemeClr val="accent1"/>
-          </a:fillRef>
-          <a:effectRef idx="2">
-            <a:schemeClr val="accent1"/>
-          </a:effectRef>
-          <a:fontRef idx="minor">
-            <a:schemeClr val="lt1"/>
-          </a:fontRef>
-        </p:style>
-        <p:txBody>
-          <a:bodyPr rtlCol="0" anchor="ctr"/>
-          <a:lstStyle/>
-          <a:p>
-            <a:pPr algn="ctr"/>
-            <a:endParaRPr/>
-          </a:p>
-        </p:txBody>
-      </p:sp>
-      <p:sp>
-        <p:nvSpPr>
-          <p:cNvPr id="3" name="Rectangle 2"/>
-          <p:cNvSpPr/>
-          <p:nvPr/>
-        </p:nvSpPr>
-        <p:spPr>
-          <a:xfrm>
-            <a:off x="0" y="868680"/>
-            <a:ext cx="12191695" cy="54864"/>
-          </a:xfrm>
-          <a:prstGeom prst="rect">
-            <a:avLst/>
-          </a:prstGeom>
-          <a:solidFill>
-            <a:srgbClr val="0E7490"/>
-          </a:solidFill>
-          <a:ln>
-            <a:noFill/>
-          </a:ln>
-          <a:effectLst/>
-        </p:spPr>
-        <p:style>
-          <a:lnRef idx="1">
-            <a:schemeClr val="accent1"/>
-          </a:lnRef>
-          <a:fillRef idx="3">
-            <a:schemeClr val="accent1"/>
-          </a:fillRef>
-          <a:effectRef idx="2">
-            <a:schemeClr val="accent1"/>
-          </a:effectRef>
-          <a:fontRef idx="minor">
-            <a:schemeClr val="lt1"/>
-          </a:fontRef>
-        </p:style>
-        <p:txBody>
-          <a:bodyPr rtlCol="0" anchor="ctr"/>
-          <a:lstStyle/>
-          <a:p>
-            <a:pPr algn="ctr"/>
-            <a:endParaRPr/>
-          </a:p>
-        </p:txBody>
-      </p:sp>
-      <p:sp>
-        <p:nvSpPr>
-          <p:cNvPr id="4" name="TextBox 3"/>
-          <p:cNvSpPr txBox="1"/>
-          <p:nvPr/>
-        </p:nvSpPr>
-        <p:spPr>
-          <a:xfrm>
-            <a:off x="411480" y="137160"/>
-            <a:ext cx="8412480" cy="685800"/>
-          </a:xfrm>
-          <a:prstGeom prst="rect">
-            <a:avLst/>
-          </a:prstGeom>
-          <a:noFill/>
-        </p:spPr>
-        <p:txBody>
-          <a:bodyPr wrap="square" lIns="45720" tIns="0" rIns="45720" bIns="0" anchor="t">
-            <a:spAutoFit/>
-          </a:bodyPr>
-          <a:lstStyle/>
-          <a:p>
-            <a:pPr algn="l">
-              <a:lnSpc>
-                <a:spcPct val="108000"/>
-              </a:lnSpc>
-              <a:spcBef>
-                <a:spcPts val="0"/>
-              </a:spcBef>
-              <a:spcAft>
-                <a:spcPts val="0"/>
-              </a:spcAft>
-            </a:pPr>
-            <a:r>
-              <a:rPr sz="2200" b="1">
-                <a:solidFill>
-                  <a:srgbClr val="FFFFFF"/>
-                </a:solidFill>
-                <a:latin typeface="Tahoma"/>
-              </a:rPr>
-              <a:t>ระบบถาม-ตอบเรื่องภัยออนไลน์  ทำงานอย่างไร</a:t>
-            </a:r>
-          </a:p>
-          <a:p>
-            <a:pPr algn="l">
-              <a:lnSpc>
-                <a:spcPct val="108000"/>
-              </a:lnSpc>
-              <a:spcBef>
-                <a:spcPts val="400"/>
-              </a:spcBef>
-              <a:spcAft>
-                <a:spcPts val="0"/>
-              </a:spcAft>
-            </a:pPr>
-            <a:r>
-              <a:rPr sz="1100" b="0">
-                <a:solidFill>
-                  <a:srgbClr val="A5B8D0"/>
-                </a:solidFill>
-                <a:latin typeface="Tahoma"/>
-              </a:rPr>
-              <a:t>อธิบายแบบไม่ต้องรู้เรื่องโปรแกรม</a:t>
-            </a:r>
-          </a:p>
-        </p:txBody>
-      </p:sp>
-      <p:sp>
-        <p:nvSpPr>
           <p:cNvPr id="5" name="TextBox 4"/>
           <p:cNvSpPr txBox="1"/>
           <p:nvPr/>
@@ -3317,10 +3160,10 @@
       </p:sp>
       <p:pic>
         <p:nvPicPr>
-          <p:cNvPr id="61" name="Picture 60" descr="generated-image.png">
+          <p:cNvPr id="7" name="Picture 6">
             <a:extLst>
               <a:ext uri="{FF2B5EF4-FFF2-40B4-BE49-F238E27FC236}">
-                <a16:creationId xmlns:a16="http://schemas.microsoft.com/office/drawing/2014/main" id="{9041F815-DAC9-9B18-E806-9ABF8A2AC879}"/>
+                <a16:creationId xmlns:a16="http://schemas.microsoft.com/office/drawing/2014/main" id="{BEF43FDB-C1E5-8870-B99A-561D9445C9E8}"/>
               </a:ext>
             </a:extLst>
           </p:cNvPr>
@@ -3337,8 +3180,8 @@
         </p:blipFill>
         <p:spPr>
           <a:xfrm>
-            <a:off x="1681332" y="971981"/>
-            <a:ext cx="8829029" cy="5886019"/>
+            <a:off x="0" y="0"/>
+            <a:ext cx="12192000" cy="6858000"/>
           </a:xfrm>
           <a:prstGeom prst="rect">
             <a:avLst/>
@@ -3372,51 +3215,6 @@
       </p:grpSpPr>
       <p:sp>
         <p:nvSpPr>
-          <p:cNvPr id="2" name="Rectangle 1"/>
-          <p:cNvSpPr/>
-          <p:nvPr/>
-        </p:nvSpPr>
-        <p:spPr>
-          <a:xfrm>
-            <a:off x="0" y="0"/>
-            <a:ext cx="12191695" cy="868680"/>
-          </a:xfrm>
-          <a:prstGeom prst="rect">
-            <a:avLst/>
-          </a:prstGeom>
-          <a:solidFill>
-            <a:srgbClr val="11223A"/>
-          </a:solidFill>
-          <a:ln>
-            <a:noFill/>
-          </a:ln>
-          <a:effectLst/>
-        </p:spPr>
-        <p:style>
-          <a:lnRef idx="1">
-            <a:schemeClr val="accent1"/>
-          </a:lnRef>
-          <a:fillRef idx="3">
-            <a:schemeClr val="accent1"/>
-          </a:fillRef>
-          <a:effectRef idx="2">
-            <a:schemeClr val="accent1"/>
-          </a:effectRef>
-          <a:fontRef idx="minor">
-            <a:schemeClr val="lt1"/>
-          </a:fontRef>
-        </p:style>
-        <p:txBody>
-          <a:bodyPr rtlCol="0" anchor="ctr"/>
-          <a:lstStyle/>
-          <a:p>
-            <a:pPr algn="ctr"/>
-            <a:endParaRPr/>
-          </a:p>
-        </p:txBody>
-      </p:sp>
-      <p:sp>
-        <p:nvSpPr>
           <p:cNvPr id="3" name="Rectangle 2"/>
           <p:cNvSpPr/>
           <p:nvPr/>
@@ -3594,1890 +3392,36 @@
           </a:p>
         </p:txBody>
       </p:sp>
-      <p:sp>
-        <p:nvSpPr>
-          <p:cNvPr id="6" name="Rounded Rectangle 5"/>
-          <p:cNvSpPr/>
+      <p:pic>
+        <p:nvPicPr>
+          <p:cNvPr id="41" name="Picture 40">
+            <a:extLst>
+              <a:ext uri="{FF2B5EF4-FFF2-40B4-BE49-F238E27FC236}">
+                <a16:creationId xmlns:a16="http://schemas.microsoft.com/office/drawing/2014/main" id="{F19B0518-EB73-8D8A-2793-E9735D58C964}"/>
+              </a:ext>
+            </a:extLst>
+          </p:cNvPr>
+          <p:cNvPicPr>
+            <a:picLocks noChangeAspect="1"/>
+          </p:cNvPicPr>
           <p:nvPr/>
-        </p:nvSpPr>
+        </p:nvPicPr>
+        <p:blipFill>
+          <a:blip r:embed="rId2"/>
+          <a:stretch>
+            <a:fillRect/>
+          </a:stretch>
+        </p:blipFill>
         <p:spPr>
           <a:xfrm>
-            <a:off x="384048" y="1115568"/>
-            <a:ext cx="5623560" cy="3127248"/>
-          </a:xfrm>
-          <a:prstGeom prst="roundRect">
-            <a:avLst>
-              <a:gd name="adj" fmla="val 10000"/>
-            </a:avLst>
-          </a:prstGeom>
-          <a:solidFill>
-            <a:srgbClr val="FFFFFF"/>
-          </a:solidFill>
-          <a:ln w="12700">
-            <a:solidFill>
-              <a:srgbClr val="D8DEE7"/>
-            </a:solidFill>
-          </a:ln>
-          <a:effectLst/>
-        </p:spPr>
-        <p:style>
-          <a:lnRef idx="1">
-            <a:schemeClr val="accent1"/>
-          </a:lnRef>
-          <a:fillRef idx="3">
-            <a:schemeClr val="accent1"/>
-          </a:fillRef>
-          <a:effectRef idx="2">
-            <a:schemeClr val="accent1"/>
-          </a:effectRef>
-          <a:fontRef idx="minor">
-            <a:schemeClr val="lt1"/>
-          </a:fontRef>
-        </p:style>
-        <p:txBody>
-          <a:bodyPr rtlCol="0" anchor="ctr"/>
-          <a:lstStyle/>
-          <a:p>
-            <a:pPr algn="ctr"/>
-            <a:endParaRPr/>
-          </a:p>
-        </p:txBody>
-      </p:sp>
-      <p:sp>
-        <p:nvSpPr>
-          <p:cNvPr id="7" name="Rectangle 6"/>
-          <p:cNvSpPr/>
-          <p:nvPr/>
-        </p:nvSpPr>
-        <p:spPr>
-          <a:xfrm>
-            <a:off x="384048" y="1115568"/>
-            <a:ext cx="5623560" cy="68580"/>
+            <a:off x="0" y="0"/>
+            <a:ext cx="12192000" cy="6858000"/>
           </a:xfrm>
           <a:prstGeom prst="rect">
             <a:avLst/>
           </a:prstGeom>
-          <a:solidFill>
-            <a:srgbClr val="0E7490"/>
-          </a:solidFill>
-          <a:ln>
-            <a:noFill/>
-          </a:ln>
-          <a:effectLst/>
         </p:spPr>
-        <p:style>
-          <a:lnRef idx="1">
-            <a:schemeClr val="accent1"/>
-          </a:lnRef>
-          <a:fillRef idx="3">
-            <a:schemeClr val="accent1"/>
-          </a:fillRef>
-          <a:effectRef idx="2">
-            <a:schemeClr val="accent1"/>
-          </a:effectRef>
-          <a:fontRef idx="minor">
-            <a:schemeClr val="lt1"/>
-          </a:fontRef>
-        </p:style>
-        <p:txBody>
-          <a:bodyPr rtlCol="0" anchor="ctr"/>
-          <a:lstStyle/>
-          <a:p>
-            <a:pPr algn="ctr"/>
-            <a:endParaRPr/>
-          </a:p>
-        </p:txBody>
-      </p:sp>
-      <p:sp>
-        <p:nvSpPr>
-          <p:cNvPr id="8" name="TextBox 7"/>
-          <p:cNvSpPr txBox="1"/>
-          <p:nvPr/>
-        </p:nvSpPr>
-        <p:spPr>
-          <a:xfrm>
-            <a:off x="621792" y="1316736"/>
-            <a:ext cx="5212080" cy="457200"/>
-          </a:xfrm>
-          <a:prstGeom prst="rect">
-            <a:avLst/>
-          </a:prstGeom>
-          <a:noFill/>
-        </p:spPr>
-        <p:txBody>
-          <a:bodyPr wrap="square" lIns="45720" tIns="0" rIns="45720" bIns="0" anchor="t">
-            <a:spAutoFit/>
-          </a:bodyPr>
-          <a:lstStyle/>
-          <a:p>
-            <a:pPr algn="l">
-              <a:lnSpc>
-                <a:spcPct val="108000"/>
-              </a:lnSpc>
-              <a:spcBef>
-                <a:spcPts val="0"/>
-              </a:spcBef>
-              <a:spcAft>
-                <a:spcPts val="0"/>
-              </a:spcAft>
-            </a:pPr>
-            <a:r>
-              <a:rPr sz="1500" b="1">
-                <a:solidFill>
-                  <a:srgbClr val="11223A"/>
-                </a:solidFill>
-                <a:latin typeface="Tahoma"/>
-              </a:rPr>
-              <a:t>จุดเด่น : ค้นหา 2 แบบพร้อมกัน</a:t>
-            </a:r>
-          </a:p>
-          <a:p>
-            <a:pPr algn="l">
-              <a:lnSpc>
-                <a:spcPct val="108000"/>
-              </a:lnSpc>
-              <a:spcBef>
-                <a:spcPts val="300"/>
-              </a:spcBef>
-              <a:spcAft>
-                <a:spcPts val="0"/>
-              </a:spcAft>
-            </a:pPr>
-            <a:r>
-              <a:rPr sz="1050" b="0">
-                <a:solidFill>
-                  <a:srgbClr val="5B667B"/>
-                </a:solidFill>
-                <a:latin typeface="Tahoma"/>
-              </a:rPr>
-              <a:t>ระบบทั่วไปมักเลือกอย่างใดอย่างหนึ่ง แต่ระบบนี้ใช้ทั้งคู่แล้วเอาผลมารวมกัน</a:t>
-            </a:r>
-          </a:p>
-        </p:txBody>
-      </p:sp>
-      <p:sp>
-        <p:nvSpPr>
-          <p:cNvPr id="9" name="Rounded Rectangle 8"/>
-          <p:cNvSpPr/>
-          <p:nvPr/>
-        </p:nvSpPr>
-        <p:spPr>
-          <a:xfrm>
-            <a:off x="621792" y="2066543"/>
-            <a:ext cx="5148072" cy="859536"/>
-          </a:xfrm>
-          <a:prstGeom prst="roundRect">
-            <a:avLst>
-              <a:gd name="adj" fmla="val 14000"/>
-            </a:avLst>
-          </a:prstGeom>
-          <a:solidFill>
-            <a:srgbClr val="F5F8FB"/>
-          </a:solidFill>
-          <a:ln>
-            <a:noFill/>
-          </a:ln>
-          <a:effectLst/>
-        </p:spPr>
-        <p:style>
-          <a:lnRef idx="1">
-            <a:schemeClr val="accent1"/>
-          </a:lnRef>
-          <a:fillRef idx="3">
-            <a:schemeClr val="accent1"/>
-          </a:fillRef>
-          <a:effectRef idx="2">
-            <a:schemeClr val="accent1"/>
-          </a:effectRef>
-          <a:fontRef idx="minor">
-            <a:schemeClr val="lt1"/>
-          </a:fontRef>
-        </p:style>
-        <p:txBody>
-          <a:bodyPr rtlCol="0" anchor="ctr"/>
-          <a:lstStyle/>
-          <a:p>
-            <a:pPr algn="ctr"/>
-            <a:endParaRPr/>
-          </a:p>
-        </p:txBody>
-      </p:sp>
-      <p:sp>
-        <p:nvSpPr>
-          <p:cNvPr id="10" name="Rectangle 9"/>
-          <p:cNvSpPr/>
-          <p:nvPr/>
-        </p:nvSpPr>
-        <p:spPr>
-          <a:xfrm>
-            <a:off x="621792" y="2066543"/>
-            <a:ext cx="54864" cy="859536"/>
-          </a:xfrm>
-          <a:prstGeom prst="rect">
-            <a:avLst/>
-          </a:prstGeom>
-          <a:solidFill>
-            <a:srgbClr val="1D4ED8"/>
-          </a:solidFill>
-          <a:ln>
-            <a:noFill/>
-          </a:ln>
-          <a:effectLst/>
-        </p:spPr>
-        <p:style>
-          <a:lnRef idx="1">
-            <a:schemeClr val="accent1"/>
-          </a:lnRef>
-          <a:fillRef idx="3">
-            <a:schemeClr val="accent1"/>
-          </a:fillRef>
-          <a:effectRef idx="2">
-            <a:schemeClr val="accent1"/>
-          </a:effectRef>
-          <a:fontRef idx="minor">
-            <a:schemeClr val="lt1"/>
-          </a:fontRef>
-        </p:style>
-        <p:txBody>
-          <a:bodyPr rtlCol="0" anchor="ctr"/>
-          <a:lstStyle/>
-          <a:p>
-            <a:pPr algn="ctr"/>
-            <a:endParaRPr/>
-          </a:p>
-        </p:txBody>
-      </p:sp>
-      <p:sp>
-        <p:nvSpPr>
-          <p:cNvPr id="11" name="TextBox 10"/>
-          <p:cNvSpPr txBox="1"/>
-          <p:nvPr/>
-        </p:nvSpPr>
-        <p:spPr>
-          <a:xfrm>
-            <a:off x="786384" y="2167127"/>
-            <a:ext cx="4892040" cy="731520"/>
-          </a:xfrm>
-          <a:prstGeom prst="rect">
-            <a:avLst/>
-          </a:prstGeom>
-          <a:noFill/>
-        </p:spPr>
-        <p:txBody>
-          <a:bodyPr wrap="square" lIns="45720" tIns="0" rIns="45720" bIns="0" anchor="t">
-            <a:spAutoFit/>
-          </a:bodyPr>
-          <a:lstStyle/>
-          <a:p>
-            <a:pPr algn="l">
-              <a:lnSpc>
-                <a:spcPct val="108000"/>
-              </a:lnSpc>
-              <a:spcBef>
-                <a:spcPts val="0"/>
-              </a:spcBef>
-              <a:spcAft>
-                <a:spcPts val="0"/>
-              </a:spcAft>
-            </a:pPr>
-            <a:r>
-              <a:rPr sz="1150" b="1">
-                <a:solidFill>
-                  <a:srgbClr val="1D4ED8"/>
-                </a:solidFill>
-                <a:latin typeface="Tahoma"/>
-              </a:rPr>
-              <a:t>แบบที่ 1  ค้นจากคำที่ตรงกัน</a:t>
-            </a:r>
-          </a:p>
-          <a:p>
-            <a:pPr algn="l">
-              <a:lnSpc>
-                <a:spcPct val="108000"/>
-              </a:lnSpc>
-              <a:spcBef>
-                <a:spcPts val="300"/>
-              </a:spcBef>
-              <a:spcAft>
-                <a:spcPts val="0"/>
-              </a:spcAft>
-            </a:pPr>
-            <a:r>
-              <a:rPr sz="1000" b="0">
-                <a:solidFill>
-                  <a:srgbClr val="3A465C"/>
-                </a:solidFill>
-                <a:latin typeface="Tahoma"/>
-              </a:rPr>
-              <a:t>เหมือนกด Ctrl+F หาคำ  ถ้าผู้ใช้พิมพ์คำเดียวกับในคู่มือ จะเจอแม่นมาก</a:t>
-            </a:r>
-          </a:p>
-          <a:p>
-            <a:pPr algn="l">
-              <a:lnSpc>
-                <a:spcPct val="108000"/>
-              </a:lnSpc>
-              <a:spcBef>
-                <a:spcPts val="200"/>
-              </a:spcBef>
-              <a:spcAft>
-                <a:spcPts val="0"/>
-              </a:spcAft>
-            </a:pPr>
-            <a:r>
-              <a:rPr sz="950" b="0">
-                <a:solidFill>
-                  <a:srgbClr val="5B667B"/>
-                </a:solidFill>
-                <a:latin typeface="Tahoma"/>
-              </a:rPr>
-              <a:t>ข้อเสีย : พิมพ์คนละคำ ความหมายเดียวกัน ก็หาไม่เจอ</a:t>
-            </a:r>
-          </a:p>
-        </p:txBody>
-      </p:sp>
-      <p:sp>
-        <p:nvSpPr>
-          <p:cNvPr id="12" name="Rounded Rectangle 11"/>
-          <p:cNvSpPr/>
-          <p:nvPr/>
-        </p:nvSpPr>
-        <p:spPr>
-          <a:xfrm>
-            <a:off x="621792" y="3035808"/>
-            <a:ext cx="5148072" cy="859536"/>
-          </a:xfrm>
-          <a:prstGeom prst="roundRect">
-            <a:avLst>
-              <a:gd name="adj" fmla="val 14000"/>
-            </a:avLst>
-          </a:prstGeom>
-          <a:solidFill>
-            <a:srgbClr val="F5F8FB"/>
-          </a:solidFill>
-          <a:ln>
-            <a:noFill/>
-          </a:ln>
-          <a:effectLst/>
-        </p:spPr>
-        <p:style>
-          <a:lnRef idx="1">
-            <a:schemeClr val="accent1"/>
-          </a:lnRef>
-          <a:fillRef idx="3">
-            <a:schemeClr val="accent1"/>
-          </a:fillRef>
-          <a:effectRef idx="2">
-            <a:schemeClr val="accent1"/>
-          </a:effectRef>
-          <a:fontRef idx="minor">
-            <a:schemeClr val="lt1"/>
-          </a:fontRef>
-        </p:style>
-        <p:txBody>
-          <a:bodyPr rtlCol="0" anchor="ctr"/>
-          <a:lstStyle/>
-          <a:p>
-            <a:pPr algn="ctr"/>
-            <a:endParaRPr/>
-          </a:p>
-        </p:txBody>
-      </p:sp>
-      <p:sp>
-        <p:nvSpPr>
-          <p:cNvPr id="13" name="Rectangle 12"/>
-          <p:cNvSpPr/>
-          <p:nvPr/>
-        </p:nvSpPr>
-        <p:spPr>
-          <a:xfrm>
-            <a:off x="621792" y="3035808"/>
-            <a:ext cx="54864" cy="859536"/>
-          </a:xfrm>
-          <a:prstGeom prst="rect">
-            <a:avLst/>
-          </a:prstGeom>
-          <a:solidFill>
-            <a:srgbClr val="6D28D9"/>
-          </a:solidFill>
-          <a:ln>
-            <a:noFill/>
-          </a:ln>
-          <a:effectLst/>
-        </p:spPr>
-        <p:style>
-          <a:lnRef idx="1">
-            <a:schemeClr val="accent1"/>
-          </a:lnRef>
-          <a:fillRef idx="3">
-            <a:schemeClr val="accent1"/>
-          </a:fillRef>
-          <a:effectRef idx="2">
-            <a:schemeClr val="accent1"/>
-          </a:effectRef>
-          <a:fontRef idx="minor">
-            <a:schemeClr val="lt1"/>
-          </a:fontRef>
-        </p:style>
-        <p:txBody>
-          <a:bodyPr rtlCol="0" anchor="ctr"/>
-          <a:lstStyle/>
-          <a:p>
-            <a:pPr algn="ctr"/>
-            <a:endParaRPr/>
-          </a:p>
-        </p:txBody>
-      </p:sp>
-      <p:sp>
-        <p:nvSpPr>
-          <p:cNvPr id="14" name="TextBox 13"/>
-          <p:cNvSpPr txBox="1"/>
-          <p:nvPr/>
-        </p:nvSpPr>
-        <p:spPr>
-          <a:xfrm>
-            <a:off x="786384" y="3136391"/>
-            <a:ext cx="4892040" cy="731520"/>
-          </a:xfrm>
-          <a:prstGeom prst="rect">
-            <a:avLst/>
-          </a:prstGeom>
-          <a:noFill/>
-        </p:spPr>
-        <p:txBody>
-          <a:bodyPr wrap="square" lIns="45720" tIns="0" rIns="45720" bIns="0" anchor="t">
-            <a:spAutoFit/>
-          </a:bodyPr>
-          <a:lstStyle/>
-          <a:p>
-            <a:pPr algn="l">
-              <a:lnSpc>
-                <a:spcPct val="108000"/>
-              </a:lnSpc>
-              <a:spcBef>
-                <a:spcPts val="0"/>
-              </a:spcBef>
-              <a:spcAft>
-                <a:spcPts val="0"/>
-              </a:spcAft>
-            </a:pPr>
-            <a:r>
-              <a:rPr sz="1150" b="1">
-                <a:solidFill>
-                  <a:srgbClr val="6D28D9"/>
-                </a:solidFill>
-                <a:latin typeface="Tahoma"/>
-              </a:rPr>
-              <a:t>แบบที่ 2  ค้นจากความหมาย</a:t>
-            </a:r>
-          </a:p>
-          <a:p>
-            <a:pPr algn="l">
-              <a:lnSpc>
-                <a:spcPct val="108000"/>
-              </a:lnSpc>
-              <a:spcBef>
-                <a:spcPts val="300"/>
-              </a:spcBef>
-              <a:spcAft>
-                <a:spcPts val="0"/>
-              </a:spcAft>
-            </a:pPr>
-            <a:r>
-              <a:rPr sz="1000" b="0">
-                <a:solidFill>
-                  <a:srgbClr val="3A465C"/>
-                </a:solidFill>
-                <a:latin typeface="Tahoma"/>
-              </a:rPr>
-              <a:t>ระบบเข้าใจว่า “โดนดูดเงินจากแบงก์” กับ “แอปดูดเงิน” พูดถึงเรื่องเดียวกัน</a:t>
-            </a:r>
-          </a:p>
-          <a:p>
-            <a:pPr algn="l">
-              <a:lnSpc>
-                <a:spcPct val="108000"/>
-              </a:lnSpc>
-              <a:spcBef>
-                <a:spcPts val="200"/>
-              </a:spcBef>
-              <a:spcAft>
-                <a:spcPts val="0"/>
-              </a:spcAft>
-            </a:pPr>
-            <a:r>
-              <a:rPr sz="950" b="0">
-                <a:solidFill>
-                  <a:srgbClr val="5B667B"/>
-                </a:solidFill>
-                <a:latin typeface="Tahoma"/>
-              </a:rPr>
-              <a:t>ข้อเสีย : บางครั้งสับสนระหว่างเรื่องที่คล้ายกัน</a:t>
-            </a:r>
-          </a:p>
-        </p:txBody>
-      </p:sp>
-      <p:sp>
-        <p:nvSpPr>
-          <p:cNvPr id="15" name="Rounded Rectangle 14"/>
-          <p:cNvSpPr/>
-          <p:nvPr/>
-        </p:nvSpPr>
-        <p:spPr>
-          <a:xfrm>
-            <a:off x="621792" y="4023360"/>
-            <a:ext cx="5148072" cy="0"/>
-          </a:xfrm>
-          <a:prstGeom prst="roundRect">
-            <a:avLst>
-              <a:gd name="adj" fmla="val 10000"/>
-            </a:avLst>
-          </a:prstGeom>
-          <a:noFill/>
-          <a:ln>
-            <a:noFill/>
-          </a:ln>
-          <a:effectLst/>
-        </p:spPr>
-        <p:style>
-          <a:lnRef idx="1">
-            <a:schemeClr val="accent1"/>
-          </a:lnRef>
-          <a:fillRef idx="3">
-            <a:schemeClr val="accent1"/>
-          </a:fillRef>
-          <a:effectRef idx="2">
-            <a:schemeClr val="accent1"/>
-          </a:effectRef>
-          <a:fontRef idx="minor">
-            <a:schemeClr val="lt1"/>
-          </a:fontRef>
-        </p:style>
-        <p:txBody>
-          <a:bodyPr rtlCol="0" anchor="ctr"/>
-          <a:lstStyle/>
-          <a:p>
-            <a:pPr algn="ctr"/>
-            <a:endParaRPr/>
-          </a:p>
-        </p:txBody>
-      </p:sp>
-      <p:sp>
-        <p:nvSpPr>
-          <p:cNvPr id="16" name="Rounded Rectangle 15"/>
-          <p:cNvSpPr/>
-          <p:nvPr/>
-        </p:nvSpPr>
-        <p:spPr>
-          <a:xfrm>
-            <a:off x="384048" y="4315968"/>
-            <a:ext cx="5623560" cy="786384"/>
-          </a:xfrm>
-          <a:prstGeom prst="roundRect">
-            <a:avLst>
-              <a:gd name="adj" fmla="val 10000"/>
-            </a:avLst>
-          </a:prstGeom>
-          <a:solidFill>
-            <a:srgbClr val="EBF4F8"/>
-          </a:solidFill>
-          <a:ln w="12700">
-            <a:solidFill>
-              <a:srgbClr val="0E7490"/>
-            </a:solidFill>
-          </a:ln>
-          <a:effectLst/>
-        </p:spPr>
-        <p:style>
-          <a:lnRef idx="1">
-            <a:schemeClr val="accent1"/>
-          </a:lnRef>
-          <a:fillRef idx="3">
-            <a:schemeClr val="accent1"/>
-          </a:fillRef>
-          <a:effectRef idx="2">
-            <a:schemeClr val="accent1"/>
-          </a:effectRef>
-          <a:fontRef idx="minor">
-            <a:schemeClr val="lt1"/>
-          </a:fontRef>
-        </p:style>
-        <p:txBody>
-          <a:bodyPr rtlCol="0" anchor="ctr"/>
-          <a:lstStyle/>
-          <a:p>
-            <a:pPr algn="ctr"/>
-            <a:endParaRPr/>
-          </a:p>
-        </p:txBody>
-      </p:sp>
-      <p:sp>
-        <p:nvSpPr>
-          <p:cNvPr id="17" name="TextBox 16"/>
-          <p:cNvSpPr txBox="1"/>
-          <p:nvPr/>
-        </p:nvSpPr>
-        <p:spPr>
-          <a:xfrm>
-            <a:off x="621792" y="4443984"/>
-            <a:ext cx="5166360" cy="640080"/>
-          </a:xfrm>
-          <a:prstGeom prst="rect">
-            <a:avLst/>
-          </a:prstGeom>
-          <a:noFill/>
-        </p:spPr>
-        <p:txBody>
-          <a:bodyPr wrap="square" lIns="45720" tIns="0" rIns="45720" bIns="0" anchor="t">
-            <a:spAutoFit/>
-          </a:bodyPr>
-          <a:lstStyle/>
-          <a:p>
-            <a:pPr algn="l">
-              <a:lnSpc>
-                <a:spcPct val="108000"/>
-              </a:lnSpc>
-              <a:spcBef>
-                <a:spcPts val="0"/>
-              </a:spcBef>
-              <a:spcAft>
-                <a:spcPts val="0"/>
-              </a:spcAft>
-            </a:pPr>
-            <a:r>
-              <a:rPr sz="1150" b="1">
-                <a:solidFill>
-                  <a:srgbClr val="11223A"/>
-                </a:solidFill>
-                <a:latin typeface="Tahoma"/>
-              </a:rPr>
-              <a:t>รวมผลทั้งสองแบบ  =  ครอบคลุมทั้งคนที่พิมพ์ตรงคำ และคนที่พิมพ์ภาษาพูด</a:t>
-            </a:r>
-          </a:p>
-          <a:p>
-            <a:pPr algn="l">
-              <a:lnSpc>
-                <a:spcPct val="108000"/>
-              </a:lnSpc>
-              <a:spcBef>
-                <a:spcPts val="300"/>
-              </a:spcBef>
-              <a:spcAft>
-                <a:spcPts val="0"/>
-              </a:spcAft>
-            </a:pPr>
-            <a:r>
-              <a:rPr sz="1000" b="0">
-                <a:solidFill>
-                  <a:srgbClr val="2C3A50"/>
-                </a:solidFill>
-                <a:latin typeface="Tahoma"/>
-              </a:rPr>
-              <a:t>เรื่องที่ทั้งสองวิธีเห็นตรงกันว่าเกี่ยวข้อง จะถูกดันขึ้นมาเป็นอันดับต้น</a:t>
-            </a:r>
-          </a:p>
-        </p:txBody>
-      </p:sp>
-      <p:sp>
-        <p:nvSpPr>
-          <p:cNvPr id="18" name="Rounded Rectangle 17"/>
-          <p:cNvSpPr/>
-          <p:nvPr/>
-        </p:nvSpPr>
-        <p:spPr>
-          <a:xfrm>
-            <a:off x="6181344" y="1115568"/>
-            <a:ext cx="5623560" cy="3986784"/>
-          </a:xfrm>
-          <a:prstGeom prst="roundRect">
-            <a:avLst>
-              <a:gd name="adj" fmla="val 10000"/>
-            </a:avLst>
-          </a:prstGeom>
-          <a:solidFill>
-            <a:srgbClr val="FFFFFF"/>
-          </a:solidFill>
-          <a:ln w="12700">
-            <a:solidFill>
-              <a:srgbClr val="D8DEE7"/>
-            </a:solidFill>
-          </a:ln>
-          <a:effectLst/>
-        </p:spPr>
-        <p:style>
-          <a:lnRef idx="1">
-            <a:schemeClr val="accent1"/>
-          </a:lnRef>
-          <a:fillRef idx="3">
-            <a:schemeClr val="accent1"/>
-          </a:fillRef>
-          <a:effectRef idx="2">
-            <a:schemeClr val="accent1"/>
-          </a:effectRef>
-          <a:fontRef idx="minor">
-            <a:schemeClr val="lt1"/>
-          </a:fontRef>
-        </p:style>
-        <p:txBody>
-          <a:bodyPr rtlCol="0" anchor="ctr"/>
-          <a:lstStyle/>
-          <a:p>
-            <a:pPr algn="ctr"/>
-            <a:endParaRPr/>
-          </a:p>
-        </p:txBody>
-      </p:sp>
-      <p:sp>
-        <p:nvSpPr>
-          <p:cNvPr id="19" name="Rectangle 18"/>
-          <p:cNvSpPr/>
-          <p:nvPr/>
-        </p:nvSpPr>
-        <p:spPr>
-          <a:xfrm>
-            <a:off x="6181344" y="1115568"/>
-            <a:ext cx="5623560" cy="68580"/>
-          </a:xfrm>
-          <a:prstGeom prst="rect">
-            <a:avLst/>
-          </a:prstGeom>
-          <a:solidFill>
-            <a:srgbClr val="B45309"/>
-          </a:solidFill>
-          <a:ln>
-            <a:noFill/>
-          </a:ln>
-          <a:effectLst/>
-        </p:spPr>
-        <p:style>
-          <a:lnRef idx="1">
-            <a:schemeClr val="accent1"/>
-          </a:lnRef>
-          <a:fillRef idx="3">
-            <a:schemeClr val="accent1"/>
-          </a:fillRef>
-          <a:effectRef idx="2">
-            <a:schemeClr val="accent1"/>
-          </a:effectRef>
-          <a:fontRef idx="minor">
-            <a:schemeClr val="lt1"/>
-          </a:fontRef>
-        </p:style>
-        <p:txBody>
-          <a:bodyPr rtlCol="0" anchor="ctr"/>
-          <a:lstStyle/>
-          <a:p>
-            <a:pPr algn="ctr"/>
-            <a:endParaRPr/>
-          </a:p>
-        </p:txBody>
-      </p:sp>
-      <p:sp>
-        <p:nvSpPr>
-          <p:cNvPr id="20" name="TextBox 19"/>
-          <p:cNvSpPr txBox="1"/>
-          <p:nvPr/>
-        </p:nvSpPr>
-        <p:spPr>
-          <a:xfrm>
-            <a:off x="6419088" y="1316736"/>
-            <a:ext cx="5212080" cy="320040"/>
-          </a:xfrm>
-          <a:prstGeom prst="rect">
-            <a:avLst/>
-          </a:prstGeom>
-          <a:noFill/>
-        </p:spPr>
-        <p:txBody>
-          <a:bodyPr wrap="square" lIns="45720" tIns="0" rIns="45720" bIns="0" anchor="t">
-            <a:spAutoFit/>
-          </a:bodyPr>
-          <a:lstStyle/>
-          <a:p>
-            <a:pPr algn="l">
-              <a:lnSpc>
-                <a:spcPct val="108000"/>
-              </a:lnSpc>
-              <a:spcBef>
-                <a:spcPts val="0"/>
-              </a:spcBef>
-              <a:spcAft>
-                <a:spcPts val="0"/>
-              </a:spcAft>
-            </a:pPr>
-            <a:r>
-              <a:rPr sz="1500" b="1">
-                <a:solidFill>
-                  <a:srgbClr val="11223A"/>
-                </a:solidFill>
-                <a:latin typeface="Tahoma"/>
-              </a:rPr>
-              <a:t>ตัวอย่างการใช้งานจริง</a:t>
-            </a:r>
-          </a:p>
-        </p:txBody>
-      </p:sp>
-      <p:sp>
-        <p:nvSpPr>
-          <p:cNvPr id="21" name="Rounded Rectangle 20"/>
-          <p:cNvSpPr/>
-          <p:nvPr/>
-        </p:nvSpPr>
-        <p:spPr>
-          <a:xfrm>
-            <a:off x="6419088" y="1755648"/>
-            <a:ext cx="5148072" cy="457200"/>
-          </a:xfrm>
-          <a:prstGeom prst="roundRect">
-            <a:avLst>
-              <a:gd name="adj" fmla="val 20000"/>
-            </a:avLst>
-          </a:prstGeom>
-          <a:solidFill>
-            <a:srgbClr val="EFF3F8"/>
-          </a:solidFill>
-          <a:ln>
-            <a:noFill/>
-          </a:ln>
-          <a:effectLst/>
-        </p:spPr>
-        <p:style>
-          <a:lnRef idx="1">
-            <a:schemeClr val="accent1"/>
-          </a:lnRef>
-          <a:fillRef idx="3">
-            <a:schemeClr val="accent1"/>
-          </a:fillRef>
-          <a:effectRef idx="2">
-            <a:schemeClr val="accent1"/>
-          </a:effectRef>
-          <a:fontRef idx="minor">
-            <a:schemeClr val="lt1"/>
-          </a:fontRef>
-        </p:style>
-        <p:txBody>
-          <a:bodyPr rtlCol="0" anchor="ctr"/>
-          <a:lstStyle/>
-          <a:p>
-            <a:pPr algn="ctr"/>
-            <a:endParaRPr/>
-          </a:p>
-        </p:txBody>
-      </p:sp>
-      <p:sp>
-        <p:nvSpPr>
-          <p:cNvPr id="22" name="TextBox 21"/>
-          <p:cNvSpPr txBox="1"/>
-          <p:nvPr/>
-        </p:nvSpPr>
-        <p:spPr>
-          <a:xfrm>
-            <a:off x="6565392" y="1847088"/>
-            <a:ext cx="4937760" cy="365760"/>
-          </a:xfrm>
-          <a:prstGeom prst="rect">
-            <a:avLst/>
-          </a:prstGeom>
-          <a:noFill/>
-        </p:spPr>
-        <p:txBody>
-          <a:bodyPr wrap="square" lIns="45720" tIns="0" rIns="45720" bIns="0" anchor="t">
-            <a:spAutoFit/>
-          </a:bodyPr>
-          <a:lstStyle/>
-          <a:p>
-            <a:pPr algn="l">
-              <a:lnSpc>
-                <a:spcPct val="108000"/>
-              </a:lnSpc>
-              <a:spcBef>
-                <a:spcPts val="0"/>
-              </a:spcBef>
-              <a:spcAft>
-                <a:spcPts val="0"/>
-              </a:spcAft>
-            </a:pPr>
-            <a:r>
-              <a:rPr sz="1150" b="1">
-                <a:solidFill>
-                  <a:srgbClr val="1D4ED8"/>
-                </a:solidFill>
-                <a:latin typeface="Tahoma"/>
-              </a:rPr>
-              <a:t>คำถาม :  OTP คืออะไร ทำไมห้ามบอกคนอื่น</a:t>
-            </a:r>
-          </a:p>
-        </p:txBody>
-      </p:sp>
-      <p:sp>
-        <p:nvSpPr>
-          <p:cNvPr id="23" name="TextBox 22"/>
-          <p:cNvSpPr txBox="1"/>
-          <p:nvPr/>
-        </p:nvSpPr>
-        <p:spPr>
-          <a:xfrm>
-            <a:off x="6419088" y="2359152"/>
-            <a:ext cx="5166360" cy="1371600"/>
-          </a:xfrm>
-          <a:prstGeom prst="rect">
-            <a:avLst/>
-          </a:prstGeom>
-          <a:noFill/>
-        </p:spPr>
-        <p:txBody>
-          <a:bodyPr wrap="square" lIns="45720" tIns="0" rIns="45720" bIns="0" anchor="t">
-            <a:spAutoFit/>
-          </a:bodyPr>
-          <a:lstStyle/>
-          <a:p>
-            <a:pPr algn="l">
-              <a:lnSpc>
-                <a:spcPct val="108000"/>
-              </a:lnSpc>
-              <a:spcBef>
-                <a:spcPts val="0"/>
-              </a:spcBef>
-              <a:spcAft>
-                <a:spcPts val="0"/>
-              </a:spcAft>
-            </a:pPr>
-            <a:r>
-              <a:rPr sz="900" b="1">
-                <a:solidFill>
-                  <a:srgbClr val="5B667B"/>
-                </a:solidFill>
-                <a:latin typeface="Tahoma"/>
-              </a:rPr>
-              <a:t>คำตอบของระบบ</a:t>
-            </a:r>
-          </a:p>
-          <a:p>
-            <a:pPr algn="l">
-              <a:lnSpc>
-                <a:spcPct val="108000"/>
-              </a:lnSpc>
-              <a:spcBef>
-                <a:spcPts val="400"/>
-              </a:spcBef>
-              <a:spcAft>
-                <a:spcPts val="0"/>
-              </a:spcAft>
-            </a:pPr>
-            <a:r>
-              <a:rPr sz="1050" b="0">
-                <a:solidFill>
-                  <a:srgbClr val="141B2D"/>
-                </a:solidFill>
-                <a:latin typeface="Tahoma"/>
-              </a:rPr>
-              <a:t>OTP คือรหัสผ่านครั้งเดียวที่ระบบส่งมาเพื่อยืนยันว่าผู้ทำรายการคือเจ้าของบัญชีจริง [1] มันเทียบเท่าลายเซ็นอนุมัติ และใช้สำหรับอนุมัติรายการที่กำลังทำอยู่ ไม่ใช่สำหรับยกเลิกรายการ [2] [3]</a:t>
-            </a:r>
-          </a:p>
-        </p:txBody>
-      </p:sp>
-      <p:sp>
-        <p:nvSpPr>
-          <p:cNvPr id="24" name="Rounded Rectangle 23"/>
-          <p:cNvSpPr/>
-          <p:nvPr/>
-        </p:nvSpPr>
-        <p:spPr>
-          <a:xfrm>
-            <a:off x="6419088" y="3822191"/>
-            <a:ext cx="5148072" cy="1133856"/>
-          </a:xfrm>
-          <a:prstGeom prst="roundRect">
-            <a:avLst>
-              <a:gd name="adj" fmla="val 10000"/>
-            </a:avLst>
-          </a:prstGeom>
-          <a:solidFill>
-            <a:srgbClr val="F5F8FB"/>
-          </a:solidFill>
-          <a:ln>
-            <a:noFill/>
-          </a:ln>
-          <a:effectLst/>
-        </p:spPr>
-        <p:style>
-          <a:lnRef idx="1">
-            <a:schemeClr val="accent1"/>
-          </a:lnRef>
-          <a:fillRef idx="3">
-            <a:schemeClr val="accent1"/>
-          </a:fillRef>
-          <a:effectRef idx="2">
-            <a:schemeClr val="accent1"/>
-          </a:effectRef>
-          <a:fontRef idx="minor">
-            <a:schemeClr val="lt1"/>
-          </a:fontRef>
-        </p:style>
-        <p:txBody>
-          <a:bodyPr rtlCol="0" anchor="ctr"/>
-          <a:lstStyle/>
-          <a:p>
-            <a:pPr algn="ctr"/>
-            <a:endParaRPr/>
-          </a:p>
-        </p:txBody>
-      </p:sp>
-      <p:sp>
-        <p:nvSpPr>
-          <p:cNvPr id="25" name="TextBox 24"/>
-          <p:cNvSpPr txBox="1"/>
-          <p:nvPr/>
-        </p:nvSpPr>
-        <p:spPr>
-          <a:xfrm>
-            <a:off x="6583680" y="3913632"/>
-            <a:ext cx="4846320" cy="1005840"/>
-          </a:xfrm>
-          <a:prstGeom prst="rect">
-            <a:avLst/>
-          </a:prstGeom>
-          <a:noFill/>
-        </p:spPr>
-        <p:txBody>
-          <a:bodyPr wrap="square" lIns="45720" tIns="0" rIns="45720" bIns="0" anchor="t">
-            <a:spAutoFit/>
-          </a:bodyPr>
-          <a:lstStyle/>
-          <a:p>
-            <a:pPr algn="l">
-              <a:lnSpc>
-                <a:spcPct val="108000"/>
-              </a:lnSpc>
-              <a:spcBef>
-                <a:spcPts val="0"/>
-              </a:spcBef>
-              <a:spcAft>
-                <a:spcPts val="0"/>
-              </a:spcAft>
-            </a:pPr>
-            <a:r>
-              <a:rPr sz="900" b="1">
-                <a:solidFill>
-                  <a:srgbClr val="5B667B"/>
-                </a:solidFill>
-                <a:latin typeface="Tahoma"/>
-              </a:rPr>
-              <a:t>แหล่งที่มาที่ระบบแนบมาให้ตรวจสอบ</a:t>
-            </a:r>
-          </a:p>
-          <a:p>
-            <a:pPr algn="l">
-              <a:lnSpc>
-                <a:spcPct val="108000"/>
-              </a:lnSpc>
-              <a:spcBef>
-                <a:spcPts val="400"/>
-              </a:spcBef>
-              <a:spcAft>
-                <a:spcPts val="0"/>
-              </a:spcAft>
-            </a:pPr>
-            <a:r>
-              <a:rPr sz="950" b="0">
-                <a:solidFill>
-                  <a:srgbClr val="B45309"/>
-                </a:solidFill>
-                <a:latin typeface="Tahoma"/>
-              </a:rPr>
-              <a:t>[1]  รหัส OTP คืออะไร ทำไมห้ามบอกใคร  (บรรทัด 283)</a:t>
-            </a:r>
-          </a:p>
-          <a:p>
-            <a:pPr algn="l">
-              <a:lnSpc>
-                <a:spcPct val="108000"/>
-              </a:lnSpc>
-              <a:spcBef>
-                <a:spcPts val="100"/>
-              </a:spcBef>
-              <a:spcAft>
-                <a:spcPts val="0"/>
-              </a:spcAft>
-            </a:pPr>
-            <a:r>
-              <a:rPr sz="950" b="0">
-                <a:solidFill>
-                  <a:srgbClr val="B45309"/>
-                </a:solidFill>
-                <a:latin typeface="Tahoma"/>
-              </a:rPr>
-              <a:t>[2]  มันขอ OTP บอกว่าจะช่วยยกเลิกรายการให้  (บรรทัด 1222)</a:t>
-            </a:r>
-          </a:p>
-          <a:p>
-            <a:pPr algn="l">
-              <a:lnSpc>
-                <a:spcPct val="108000"/>
-              </a:lnSpc>
-              <a:spcBef>
-                <a:spcPts val="100"/>
-              </a:spcBef>
-              <a:spcAft>
-                <a:spcPts val="0"/>
-              </a:spcAft>
-            </a:pPr>
-            <a:r>
-              <a:rPr sz="950" b="0">
-                <a:solidFill>
-                  <a:srgbClr val="B45309"/>
-                </a:solidFill>
-                <a:latin typeface="Tahoma"/>
-              </a:rPr>
-              <a:t>[3]  ธนาคารโทรมาขอ OTP บอกได้ไหม  (บรรทัด 820)</a:t>
-            </a:r>
-          </a:p>
-        </p:txBody>
-      </p:sp>
-      <p:sp>
-        <p:nvSpPr>
-          <p:cNvPr id="26" name="Rounded Rectangle 25"/>
-          <p:cNvSpPr/>
-          <p:nvPr/>
-        </p:nvSpPr>
-        <p:spPr>
-          <a:xfrm>
-            <a:off x="384048" y="5230368"/>
-            <a:ext cx="11420856" cy="1207008"/>
-          </a:xfrm>
-          <a:prstGeom prst="roundRect">
-            <a:avLst>
-              <a:gd name="adj" fmla="val 10000"/>
-            </a:avLst>
-          </a:prstGeom>
-          <a:solidFill>
-            <a:srgbClr val="FFFFFF"/>
-          </a:solidFill>
-          <a:ln w="12700">
-            <a:solidFill>
-              <a:srgbClr val="D8DEE7"/>
-            </a:solidFill>
-          </a:ln>
-          <a:effectLst/>
-        </p:spPr>
-        <p:style>
-          <a:lnRef idx="1">
-            <a:schemeClr val="accent1"/>
-          </a:lnRef>
-          <a:fillRef idx="3">
-            <a:schemeClr val="accent1"/>
-          </a:fillRef>
-          <a:effectRef idx="2">
-            <a:schemeClr val="accent1"/>
-          </a:effectRef>
-          <a:fontRef idx="minor">
-            <a:schemeClr val="lt1"/>
-          </a:fontRef>
-        </p:style>
-        <p:txBody>
-          <a:bodyPr rtlCol="0" anchor="ctr"/>
-          <a:lstStyle/>
-          <a:p>
-            <a:pPr algn="ctr"/>
-            <a:endParaRPr/>
-          </a:p>
-        </p:txBody>
-      </p:sp>
-      <p:sp>
-        <p:nvSpPr>
-          <p:cNvPr id="27" name="TextBox 26"/>
-          <p:cNvSpPr txBox="1"/>
-          <p:nvPr/>
-        </p:nvSpPr>
-        <p:spPr>
-          <a:xfrm>
-            <a:off x="603504" y="5358383"/>
-            <a:ext cx="3108960" cy="274320"/>
-          </a:xfrm>
-          <a:prstGeom prst="rect">
-            <a:avLst/>
-          </a:prstGeom>
-          <a:noFill/>
-        </p:spPr>
-        <p:txBody>
-          <a:bodyPr wrap="square" lIns="45720" tIns="0" rIns="45720" bIns="0" anchor="t">
-            <a:spAutoFit/>
-          </a:bodyPr>
-          <a:lstStyle/>
-          <a:p>
-            <a:pPr algn="l">
-              <a:lnSpc>
-                <a:spcPct val="108000"/>
-              </a:lnSpc>
-              <a:spcBef>
-                <a:spcPts val="0"/>
-              </a:spcBef>
-              <a:spcAft>
-                <a:spcPts val="0"/>
-              </a:spcAft>
-            </a:pPr>
-            <a:r>
-              <a:rPr sz="1200" b="1">
-                <a:solidFill>
-                  <a:srgbClr val="11223A"/>
-                </a:solidFill>
-                <a:latin typeface="Tahoma"/>
-              </a:rPr>
-              <a:t>ผลการทดสอบ</a:t>
-            </a:r>
-          </a:p>
-          <a:p>
-            <a:pPr algn="l">
-              <a:lnSpc>
-                <a:spcPct val="108000"/>
-              </a:lnSpc>
-              <a:spcBef>
-                <a:spcPts val="300"/>
-              </a:spcBef>
-              <a:spcAft>
-                <a:spcPts val="0"/>
-              </a:spcAft>
-            </a:pPr>
-            <a:r>
-              <a:rPr sz="950" b="0">
-                <a:solidFill>
-                  <a:srgbClr val="5B667B"/>
-                </a:solidFill>
-                <a:latin typeface="Tahoma"/>
-              </a:rPr>
-              <a:t>ทดสอบด้วยคำถาม 54 ข้อ ที่มีเฉลยไว้ล่วงหน้า</a:t>
-            </a:r>
-          </a:p>
-        </p:txBody>
-      </p:sp>
-      <p:sp>
-        <p:nvSpPr>
-          <p:cNvPr id="28" name="TextBox 27"/>
-          <p:cNvSpPr txBox="1"/>
-          <p:nvPr/>
-        </p:nvSpPr>
-        <p:spPr>
-          <a:xfrm>
-            <a:off x="3794760" y="5376672"/>
-            <a:ext cx="1874519" cy="365760"/>
-          </a:xfrm>
-          <a:prstGeom prst="rect">
-            <a:avLst/>
-          </a:prstGeom>
-          <a:noFill/>
-        </p:spPr>
-        <p:txBody>
-          <a:bodyPr wrap="square" lIns="45720" tIns="0" rIns="45720" bIns="0" anchor="t">
-            <a:spAutoFit/>
-          </a:bodyPr>
-          <a:lstStyle/>
-          <a:p>
-            <a:pPr algn="ctr">
-              <a:lnSpc>
-                <a:spcPct val="108000"/>
-              </a:lnSpc>
-              <a:spcBef>
-                <a:spcPts val="0"/>
-              </a:spcBef>
-              <a:spcAft>
-                <a:spcPts val="0"/>
-              </a:spcAft>
-            </a:pPr>
-            <a:r>
-              <a:rPr sz="2000" b="1">
-                <a:solidFill>
-                  <a:srgbClr val="15803D"/>
-                </a:solidFill>
-                <a:latin typeface="Tahoma"/>
-              </a:rPr>
-              <a:t>98.7%</a:t>
-            </a:r>
-          </a:p>
-        </p:txBody>
-      </p:sp>
-      <p:sp>
-        <p:nvSpPr>
-          <p:cNvPr id="29" name="TextBox 28"/>
-          <p:cNvSpPr txBox="1"/>
-          <p:nvPr/>
-        </p:nvSpPr>
-        <p:spPr>
-          <a:xfrm>
-            <a:off x="3794760" y="5833872"/>
-            <a:ext cx="1874519" cy="502920"/>
-          </a:xfrm>
-          <a:prstGeom prst="rect">
-            <a:avLst/>
-          </a:prstGeom>
-          <a:noFill/>
-        </p:spPr>
-        <p:txBody>
-          <a:bodyPr wrap="square" lIns="45720" tIns="0" rIns="45720" bIns="0" anchor="t">
-            <a:spAutoFit/>
-          </a:bodyPr>
-          <a:lstStyle/>
-          <a:p>
-            <a:pPr algn="ctr">
-              <a:lnSpc>
-                <a:spcPct val="108000"/>
-              </a:lnSpc>
-              <a:spcBef>
-                <a:spcPts val="0"/>
-              </a:spcBef>
-              <a:spcAft>
-                <a:spcPts val="0"/>
-              </a:spcAft>
-            </a:pPr>
-            <a:r>
-              <a:rPr sz="950" b="0">
-                <a:solidFill>
-                  <a:srgbClr val="3A465C"/>
-                </a:solidFill>
-                <a:latin typeface="Tahoma"/>
-              </a:rPr>
-              <a:t>หาคำตอบที่ถูกเจอ</a:t>
-            </a:r>
-          </a:p>
-          <a:p>
-            <a:pPr algn="ctr">
-              <a:lnSpc>
-                <a:spcPct val="108000"/>
-              </a:lnSpc>
-              <a:spcBef>
-                <a:spcPts val="0"/>
-              </a:spcBef>
-              <a:spcAft>
-                <a:spcPts val="0"/>
-              </a:spcAft>
-            </a:pPr>
-            <a:r>
-              <a:rPr sz="950" b="0">
-                <a:solidFill>
-                  <a:srgbClr val="3A465C"/>
-                </a:solidFill>
-                <a:latin typeface="Tahoma"/>
-              </a:rPr>
-              <a:t>ภายใน 3 อันดับแรก</a:t>
-            </a:r>
-          </a:p>
-        </p:txBody>
-      </p:sp>
-      <p:sp>
-        <p:nvSpPr>
-          <p:cNvPr id="30" name="Rectangle 29"/>
-          <p:cNvSpPr/>
-          <p:nvPr/>
-        </p:nvSpPr>
-        <p:spPr>
-          <a:xfrm>
-            <a:off x="5742432" y="5449824"/>
-            <a:ext cx="10972" cy="777240"/>
-          </a:xfrm>
-          <a:prstGeom prst="rect">
-            <a:avLst/>
-          </a:prstGeom>
-          <a:solidFill>
-            <a:srgbClr val="D8DEE7"/>
-          </a:solidFill>
-          <a:ln>
-            <a:noFill/>
-          </a:ln>
-          <a:effectLst/>
-        </p:spPr>
-        <p:style>
-          <a:lnRef idx="1">
-            <a:schemeClr val="accent1"/>
-          </a:lnRef>
-          <a:fillRef idx="3">
-            <a:schemeClr val="accent1"/>
-          </a:fillRef>
-          <a:effectRef idx="2">
-            <a:schemeClr val="accent1"/>
-          </a:effectRef>
-          <a:fontRef idx="minor">
-            <a:schemeClr val="lt1"/>
-          </a:fontRef>
-        </p:style>
-        <p:txBody>
-          <a:bodyPr rtlCol="0" anchor="ctr"/>
-          <a:lstStyle/>
-          <a:p>
-            <a:pPr algn="ctr"/>
-            <a:endParaRPr/>
-          </a:p>
-        </p:txBody>
-      </p:sp>
-      <p:sp>
-        <p:nvSpPr>
-          <p:cNvPr id="31" name="TextBox 30"/>
-          <p:cNvSpPr txBox="1"/>
-          <p:nvPr/>
-        </p:nvSpPr>
-        <p:spPr>
-          <a:xfrm>
-            <a:off x="5806440" y="5376672"/>
-            <a:ext cx="1874519" cy="365760"/>
-          </a:xfrm>
-          <a:prstGeom prst="rect">
-            <a:avLst/>
-          </a:prstGeom>
-          <a:noFill/>
-        </p:spPr>
-        <p:txBody>
-          <a:bodyPr wrap="square" lIns="45720" tIns="0" rIns="45720" bIns="0" anchor="t">
-            <a:spAutoFit/>
-          </a:bodyPr>
-          <a:lstStyle/>
-          <a:p>
-            <a:pPr algn="ctr">
-              <a:lnSpc>
-                <a:spcPct val="108000"/>
-              </a:lnSpc>
-              <a:spcBef>
-                <a:spcPts val="0"/>
-              </a:spcBef>
-              <a:spcAft>
-                <a:spcPts val="0"/>
-              </a:spcAft>
-            </a:pPr>
-            <a:r>
-              <a:rPr sz="2000" b="1">
-                <a:solidFill>
-                  <a:srgbClr val="1D4ED8"/>
-                </a:solidFill>
-                <a:latin typeface="Tahoma"/>
-              </a:rPr>
-              <a:t>82%</a:t>
-            </a:r>
-          </a:p>
-        </p:txBody>
-      </p:sp>
-      <p:sp>
-        <p:nvSpPr>
-          <p:cNvPr id="32" name="TextBox 31"/>
-          <p:cNvSpPr txBox="1"/>
-          <p:nvPr/>
-        </p:nvSpPr>
-        <p:spPr>
-          <a:xfrm>
-            <a:off x="5806440" y="5833872"/>
-            <a:ext cx="1874519" cy="502920"/>
-          </a:xfrm>
-          <a:prstGeom prst="rect">
-            <a:avLst/>
-          </a:prstGeom>
-          <a:noFill/>
-        </p:spPr>
-        <p:txBody>
-          <a:bodyPr wrap="square" lIns="45720" tIns="0" rIns="45720" bIns="0" anchor="t">
-            <a:spAutoFit/>
-          </a:bodyPr>
-          <a:lstStyle/>
-          <a:p>
-            <a:pPr algn="ctr">
-              <a:lnSpc>
-                <a:spcPct val="108000"/>
-              </a:lnSpc>
-              <a:spcBef>
-                <a:spcPts val="0"/>
-              </a:spcBef>
-              <a:spcAft>
-                <a:spcPts val="0"/>
-              </a:spcAft>
-            </a:pPr>
-            <a:r>
-              <a:rPr sz="950" b="0">
-                <a:solidFill>
-                  <a:srgbClr val="3A465C"/>
-                </a:solidFill>
-                <a:latin typeface="Tahoma"/>
-              </a:rPr>
-              <a:t>คำตอบอ้างอิงตาม</a:t>
-            </a:r>
-          </a:p>
-          <a:p>
-            <a:pPr algn="ctr">
-              <a:lnSpc>
-                <a:spcPct val="108000"/>
-              </a:lnSpc>
-              <a:spcBef>
-                <a:spcPts val="0"/>
-              </a:spcBef>
-              <a:spcAft>
-                <a:spcPts val="0"/>
-              </a:spcAft>
-            </a:pPr>
-            <a:r>
-              <a:rPr sz="950" b="0">
-                <a:solidFill>
-                  <a:srgbClr val="3A465C"/>
-                </a:solidFill>
-                <a:latin typeface="Tahoma"/>
-              </a:rPr>
-              <a:t>คู่มือจริง ไม่แต่งเพิ่ม</a:t>
-            </a:r>
-          </a:p>
-        </p:txBody>
-      </p:sp>
-      <p:sp>
-        <p:nvSpPr>
-          <p:cNvPr id="33" name="Rectangle 32"/>
-          <p:cNvSpPr/>
-          <p:nvPr/>
-        </p:nvSpPr>
-        <p:spPr>
-          <a:xfrm>
-            <a:off x="7754112" y="5449824"/>
-            <a:ext cx="10972" cy="777240"/>
-          </a:xfrm>
-          <a:prstGeom prst="rect">
-            <a:avLst/>
-          </a:prstGeom>
-          <a:solidFill>
-            <a:srgbClr val="D8DEE7"/>
-          </a:solidFill>
-          <a:ln>
-            <a:noFill/>
-          </a:ln>
-          <a:effectLst/>
-        </p:spPr>
-        <p:style>
-          <a:lnRef idx="1">
-            <a:schemeClr val="accent1"/>
-          </a:lnRef>
-          <a:fillRef idx="3">
-            <a:schemeClr val="accent1"/>
-          </a:fillRef>
-          <a:effectRef idx="2">
-            <a:schemeClr val="accent1"/>
-          </a:effectRef>
-          <a:fontRef idx="minor">
-            <a:schemeClr val="lt1"/>
-          </a:fontRef>
-        </p:style>
-        <p:txBody>
-          <a:bodyPr rtlCol="0" anchor="ctr"/>
-          <a:lstStyle/>
-          <a:p>
-            <a:pPr algn="ctr"/>
-            <a:endParaRPr/>
-          </a:p>
-        </p:txBody>
-      </p:sp>
-      <p:sp>
-        <p:nvSpPr>
-          <p:cNvPr id="34" name="TextBox 33"/>
-          <p:cNvSpPr txBox="1"/>
-          <p:nvPr/>
-        </p:nvSpPr>
-        <p:spPr>
-          <a:xfrm>
-            <a:off x="7818120" y="5376672"/>
-            <a:ext cx="1874519" cy="365760"/>
-          </a:xfrm>
-          <a:prstGeom prst="rect">
-            <a:avLst/>
-          </a:prstGeom>
-          <a:noFill/>
-        </p:spPr>
-        <p:txBody>
-          <a:bodyPr wrap="square" lIns="45720" tIns="0" rIns="45720" bIns="0" anchor="t">
-            <a:spAutoFit/>
-          </a:bodyPr>
-          <a:lstStyle/>
-          <a:p>
-            <a:pPr algn="ctr">
-              <a:lnSpc>
-                <a:spcPct val="108000"/>
-              </a:lnSpc>
-              <a:spcBef>
-                <a:spcPts val="0"/>
-              </a:spcBef>
-              <a:spcAft>
-                <a:spcPts val="0"/>
-              </a:spcAft>
-            </a:pPr>
-            <a:r>
-              <a:rPr sz="2000" b="1">
-                <a:solidFill>
-                  <a:srgbClr val="0E7490"/>
-                </a:solidFill>
-                <a:latin typeface="Tahoma"/>
-              </a:rPr>
-              <a:t>~4 วินาที</a:t>
-            </a:r>
-          </a:p>
-        </p:txBody>
-      </p:sp>
-      <p:sp>
-        <p:nvSpPr>
-          <p:cNvPr id="35" name="TextBox 34"/>
-          <p:cNvSpPr txBox="1"/>
-          <p:nvPr/>
-        </p:nvSpPr>
-        <p:spPr>
-          <a:xfrm>
-            <a:off x="7818120" y="5833872"/>
-            <a:ext cx="1874519" cy="502920"/>
-          </a:xfrm>
-          <a:prstGeom prst="rect">
-            <a:avLst/>
-          </a:prstGeom>
-          <a:noFill/>
-        </p:spPr>
-        <p:txBody>
-          <a:bodyPr wrap="square" lIns="45720" tIns="0" rIns="45720" bIns="0" anchor="t">
-            <a:spAutoFit/>
-          </a:bodyPr>
-          <a:lstStyle/>
-          <a:p>
-            <a:pPr algn="ctr">
-              <a:lnSpc>
-                <a:spcPct val="108000"/>
-              </a:lnSpc>
-              <a:spcBef>
-                <a:spcPts val="0"/>
-              </a:spcBef>
-              <a:spcAft>
-                <a:spcPts val="0"/>
-              </a:spcAft>
-            </a:pPr>
-            <a:r>
-              <a:rPr sz="950" b="0">
-                <a:solidFill>
-                  <a:srgbClr val="3A465C"/>
-                </a:solidFill>
-                <a:latin typeface="Tahoma"/>
-              </a:rPr>
-              <a:t>เวลาตอบเฉลี่ย</a:t>
-            </a:r>
-          </a:p>
-          <a:p>
-            <a:pPr algn="ctr">
-              <a:lnSpc>
-                <a:spcPct val="108000"/>
-              </a:lnSpc>
-              <a:spcBef>
-                <a:spcPts val="0"/>
-              </a:spcBef>
-              <a:spcAft>
-                <a:spcPts val="0"/>
-              </a:spcAft>
-            </a:pPr>
-            <a:r>
-              <a:rPr sz="950" b="0">
-                <a:solidFill>
-                  <a:srgbClr val="3A465C"/>
-                </a:solidFill>
-                <a:latin typeface="Tahoma"/>
-              </a:rPr>
-              <a:t>ต่อ 1 คำถาม</a:t>
-            </a:r>
-          </a:p>
-        </p:txBody>
-      </p:sp>
-      <p:sp>
-        <p:nvSpPr>
-          <p:cNvPr id="36" name="Rectangle 35"/>
-          <p:cNvSpPr/>
-          <p:nvPr/>
-        </p:nvSpPr>
-        <p:spPr>
-          <a:xfrm>
-            <a:off x="9765792" y="5449824"/>
-            <a:ext cx="10972" cy="777240"/>
-          </a:xfrm>
-          <a:prstGeom prst="rect">
-            <a:avLst/>
-          </a:prstGeom>
-          <a:solidFill>
-            <a:srgbClr val="D8DEE7"/>
-          </a:solidFill>
-          <a:ln>
-            <a:noFill/>
-          </a:ln>
-          <a:effectLst/>
-        </p:spPr>
-        <p:style>
-          <a:lnRef idx="1">
-            <a:schemeClr val="accent1"/>
-          </a:lnRef>
-          <a:fillRef idx="3">
-            <a:schemeClr val="accent1"/>
-          </a:fillRef>
-          <a:effectRef idx="2">
-            <a:schemeClr val="accent1"/>
-          </a:effectRef>
-          <a:fontRef idx="minor">
-            <a:schemeClr val="lt1"/>
-          </a:fontRef>
-        </p:style>
-        <p:txBody>
-          <a:bodyPr rtlCol="0" anchor="ctr"/>
-          <a:lstStyle/>
-          <a:p>
-            <a:pPr algn="ctr"/>
-            <a:endParaRPr/>
-          </a:p>
-        </p:txBody>
-      </p:sp>
-      <p:sp>
-        <p:nvSpPr>
-          <p:cNvPr id="37" name="TextBox 36"/>
-          <p:cNvSpPr txBox="1"/>
-          <p:nvPr/>
-        </p:nvSpPr>
-        <p:spPr>
-          <a:xfrm>
-            <a:off x="9829800" y="5376672"/>
-            <a:ext cx="1874519" cy="365760"/>
-          </a:xfrm>
-          <a:prstGeom prst="rect">
-            <a:avLst/>
-          </a:prstGeom>
-          <a:noFill/>
-        </p:spPr>
-        <p:txBody>
-          <a:bodyPr wrap="square" lIns="45720" tIns="0" rIns="45720" bIns="0" anchor="t">
-            <a:spAutoFit/>
-          </a:bodyPr>
-          <a:lstStyle/>
-          <a:p>
-            <a:pPr algn="ctr">
-              <a:lnSpc>
-                <a:spcPct val="108000"/>
-              </a:lnSpc>
-              <a:spcBef>
-                <a:spcPts val="0"/>
-              </a:spcBef>
-              <a:spcAft>
-                <a:spcPts val="0"/>
-              </a:spcAft>
-            </a:pPr>
-            <a:r>
-              <a:rPr sz="2000" b="1">
-                <a:solidFill>
-                  <a:srgbClr val="B45309"/>
-                </a:solidFill>
-                <a:latin typeface="Tahoma"/>
-              </a:rPr>
-              <a:t>391 เรื่อง</a:t>
-            </a:r>
-          </a:p>
-        </p:txBody>
-      </p:sp>
-      <p:sp>
-        <p:nvSpPr>
-          <p:cNvPr id="38" name="TextBox 37"/>
-          <p:cNvSpPr txBox="1"/>
-          <p:nvPr/>
-        </p:nvSpPr>
-        <p:spPr>
-          <a:xfrm>
-            <a:off x="9829800" y="5833872"/>
-            <a:ext cx="1874519" cy="502920"/>
-          </a:xfrm>
-          <a:prstGeom prst="rect">
-            <a:avLst/>
-          </a:prstGeom>
-          <a:noFill/>
-        </p:spPr>
-        <p:txBody>
-          <a:bodyPr wrap="square" lIns="45720" tIns="0" rIns="45720" bIns="0" anchor="t">
-            <a:spAutoFit/>
-          </a:bodyPr>
-          <a:lstStyle/>
-          <a:p>
-            <a:pPr algn="ctr">
-              <a:lnSpc>
-                <a:spcPct val="108000"/>
-              </a:lnSpc>
-              <a:spcBef>
-                <a:spcPts val="0"/>
-              </a:spcBef>
-              <a:spcAft>
-                <a:spcPts val="0"/>
-              </a:spcAft>
-            </a:pPr>
-            <a:r>
-              <a:rPr sz="950" b="0">
-                <a:solidFill>
-                  <a:srgbClr val="3A465C"/>
-                </a:solidFill>
-                <a:latin typeface="Tahoma"/>
-              </a:rPr>
-              <a:t>ขนาดคลังความรู้</a:t>
-            </a:r>
-          </a:p>
-          <a:p>
-            <a:pPr algn="ctr">
-              <a:lnSpc>
-                <a:spcPct val="108000"/>
-              </a:lnSpc>
-              <a:spcBef>
-                <a:spcPts val="0"/>
-              </a:spcBef>
-              <a:spcAft>
-                <a:spcPts val="0"/>
-              </a:spcAft>
-            </a:pPr>
-            <a:r>
-              <a:rPr sz="950" b="0">
-                <a:solidFill>
-                  <a:srgbClr val="3A465C"/>
-                </a:solidFill>
-                <a:latin typeface="Tahoma"/>
-              </a:rPr>
-              <a:t>ที่ระบบใช้ตอบ</a:t>
-            </a:r>
-          </a:p>
-        </p:txBody>
-      </p:sp>
-      <p:sp>
-        <p:nvSpPr>
-          <p:cNvPr id="39" name="TextBox 38"/>
-          <p:cNvSpPr txBox="1"/>
-          <p:nvPr/>
-        </p:nvSpPr>
-        <p:spPr>
-          <a:xfrm>
-            <a:off x="384048" y="6510528"/>
-            <a:ext cx="11420856" cy="274320"/>
-          </a:xfrm>
-          <a:prstGeom prst="rect">
-            <a:avLst/>
-          </a:prstGeom>
-          <a:noFill/>
-        </p:spPr>
-        <p:txBody>
-          <a:bodyPr wrap="square" lIns="45720" tIns="0" rIns="45720" bIns="0" anchor="t">
-            <a:spAutoFit/>
-          </a:bodyPr>
-          <a:lstStyle/>
-          <a:p>
-            <a:pPr algn="ctr">
-              <a:lnSpc>
-                <a:spcPct val="108000"/>
-              </a:lnSpc>
-              <a:spcBef>
-                <a:spcPts val="0"/>
-              </a:spcBef>
-              <a:spcAft>
-                <a:spcPts val="0"/>
-              </a:spcAft>
-            </a:pPr>
-            <a:r>
-              <a:rPr sz="1000" b="0">
-                <a:solidFill>
-                  <a:srgbClr val="5B667B"/>
-                </a:solidFill>
-                <a:latin typeface="Tahoma"/>
-              </a:rPr>
-              <a:t>ข้อจำกัด :  ระบบตอบได้เฉพาะเรื่องที่มีอยู่ในคลังความรู้เท่านั้น  และเป็นข้อมูลเพื่อการศึกษา ไม่ใช่คำปรึกษากฎหมายรายกรณี</a:t>
-            </a:r>
-          </a:p>
-        </p:txBody>
-      </p:sp>
+      </p:pic>
     </p:spTree>
   </p:cSld>
   <p:clrMapOvr>

</xml_diff>